<commit_message>
Botón Inicio completo enlazado (recuadro, barra, ícono y texto) en los PDF interactivos con menú
Co-Authored-By: Claude Opus 5.5 <noreply@anthropic.com>
Claude-Session: https://claude.ai/code/session_01ECfkxKzanoc9tBzEYwq5z6
</commit_message>
<xml_diff>
--- a/entregas/creditos_curso1_modulo2/C1_M2_Inteligencia_social_PDF_interactivo_COMPLETO_con_creditos.pptx
+++ b/entregas/creditos_curso1_modulo2/C1_M2_Inteligencia_social_PDF_interactivo_COMPLETO_con_creditos.pptx
@@ -4952,7 +4952,9 @@
       </p:sp>
       <p:sp>
         <p:nvSpPr>
-          <p:cNvPr id="44" name="Google Shape;44;p1"/>
+          <p:cNvPr id="44" name="Google Shape;44;p1">
+            <a:hlinkClick action="ppaction://hlinksldjump" r:id="rId19"/>
+          </p:cNvPr>
           <p:cNvSpPr/>
           <p:nvPr/>
         </p:nvSpPr>
@@ -5011,7 +5013,9 @@
       </p:sp>
       <p:sp>
         <p:nvSpPr>
-          <p:cNvPr id="45" name="Google Shape;45;p1"/>
+          <p:cNvPr id="45" name="Google Shape;45;p1">
+            <a:hlinkClick action="ppaction://hlinksldjump" r:id="rId19"/>
+          </p:cNvPr>
           <p:cNvSpPr/>
           <p:nvPr/>
         </p:nvSpPr>
@@ -5072,7 +5076,9 @@
       </p:sp>
       <p:pic>
         <p:nvPicPr>
-          <p:cNvPr id="46" name="Google Shape;46;p1" title="correcciones sapiencia.png"/>
+          <p:cNvPr id="46" name="Google Shape;46;p1" title="correcciones sapiencia.png">
+            <a:hlinkClick action="ppaction://hlinksldjump" r:id="rId19"/>
+          </p:cNvPr>
           <p:cNvPicPr preferRelativeResize="0"/>
           <p:nvPr/>
         </p:nvPicPr>
@@ -6979,7 +6985,9 @@
       </p:sp>
       <p:sp>
         <p:nvSpPr>
-          <p:cNvPr id="74" name="Google Shape;74;p4"/>
+          <p:cNvPr id="74" name="Google Shape;74;p4">
+            <a:hlinkClick action="ppaction://hlinksldjump" r:id="rId9"/>
+          </p:cNvPr>
           <p:cNvSpPr/>
           <p:nvPr/>
         </p:nvSpPr>
@@ -7038,7 +7046,9 @@
       </p:sp>
       <p:sp>
         <p:nvSpPr>
-          <p:cNvPr id="75" name="Google Shape;75;p4"/>
+          <p:cNvPr id="75" name="Google Shape;75;p4">
+            <a:hlinkClick action="ppaction://hlinksldjump" r:id="rId9"/>
+          </p:cNvPr>
           <p:cNvSpPr/>
           <p:nvPr/>
         </p:nvSpPr>
@@ -7099,7 +7109,9 @@
       </p:sp>
       <p:pic>
         <p:nvPicPr>
-          <p:cNvPr id="76" name="Google Shape;76;p4" title="correcciones sapiencia.png"/>
+          <p:cNvPr id="76" name="Google Shape;76;p4" title="correcciones sapiencia.png">
+            <a:hlinkClick action="ppaction://hlinksldjump" r:id="rId9"/>
+          </p:cNvPr>
           <p:cNvPicPr preferRelativeResize="0"/>
           <p:nvPr/>
         </p:nvPicPr>
@@ -7127,7 +7139,7 @@
       <p:sp>
         <p:nvSpPr>
           <p:cNvPr id="77" name="Google Shape;77;p4">
-            <a:hlinkClick action="ppaction://hlinksldjump" r:id="rId12"/>
+            <a:hlinkClick action="ppaction://hlinksldjump" r:id="rId9"/>
           </p:cNvPr>
           <p:cNvSpPr txBox="1"/>
           <p:nvPr/>
@@ -10742,7 +10754,9 @@
       </p:sp>
       <p:sp>
         <p:nvSpPr>
-          <p:cNvPr id="136" name="Google Shape;136;p2"/>
+          <p:cNvPr id="136" name="Google Shape;136;p2">
+            <a:hlinkClick action="ppaction://hlinksldjump" r:id="rId12"/>
+          </p:cNvPr>
           <p:cNvSpPr/>
           <p:nvPr/>
         </p:nvSpPr>
@@ -10801,7 +10815,9 @@
       </p:sp>
       <p:sp>
         <p:nvSpPr>
-          <p:cNvPr id="137" name="Google Shape;137;p2"/>
+          <p:cNvPr id="137" name="Google Shape;137;p2">
+            <a:hlinkClick action="ppaction://hlinksldjump" r:id="rId12"/>
+          </p:cNvPr>
           <p:cNvSpPr/>
           <p:nvPr/>
         </p:nvSpPr>
@@ -10862,7 +10878,9 @@
       </p:sp>
       <p:pic>
         <p:nvPicPr>
-          <p:cNvPr id="138" name="Google Shape;138;p2" title="correcciones sapiencia.png"/>
+          <p:cNvPr id="138" name="Google Shape;138;p2" title="correcciones sapiencia.png">
+            <a:hlinkClick action="ppaction://hlinksldjump" r:id="rId12"/>
+          </p:cNvPr>
           <p:cNvPicPr preferRelativeResize="0"/>
           <p:nvPr/>
         </p:nvPicPr>
@@ -14249,7 +14267,9 @@
       </p:sp>
       <p:sp>
         <p:nvSpPr>
-          <p:cNvPr id="193" name="Google Shape;193;p16"/>
+          <p:cNvPr id="193" name="Google Shape;193;p16">
+            <a:hlinkClick action="ppaction://hlinksldjump" r:id="rId12"/>
+          </p:cNvPr>
           <p:cNvSpPr/>
           <p:nvPr/>
         </p:nvSpPr>
@@ -14308,7 +14328,9 @@
       </p:sp>
       <p:sp>
         <p:nvSpPr>
-          <p:cNvPr id="194" name="Google Shape;194;p16"/>
+          <p:cNvPr id="194" name="Google Shape;194;p16">
+            <a:hlinkClick action="ppaction://hlinksldjump" r:id="rId12"/>
+          </p:cNvPr>
           <p:cNvSpPr/>
           <p:nvPr/>
         </p:nvSpPr>
@@ -14369,7 +14391,9 @@
       </p:sp>
       <p:pic>
         <p:nvPicPr>
-          <p:cNvPr id="195" name="Google Shape;195;p16" title="correcciones sapiencia.png"/>
+          <p:cNvPr id="195" name="Google Shape;195;p16" title="correcciones sapiencia.png">
+            <a:hlinkClick action="ppaction://hlinksldjump" r:id="rId12"/>
+          </p:cNvPr>
           <p:cNvPicPr preferRelativeResize="0"/>
           <p:nvPr/>
         </p:nvPicPr>
@@ -17869,7 +17893,9 @@
       </p:sp>
       <p:sp>
         <p:nvSpPr>
-          <p:cNvPr id="251" name="Google Shape;251;p17"/>
+          <p:cNvPr id="251" name="Google Shape;251;p17">
+            <a:hlinkClick action="ppaction://hlinksldjump" r:id="rId12"/>
+          </p:cNvPr>
           <p:cNvSpPr/>
           <p:nvPr/>
         </p:nvSpPr>
@@ -17928,7 +17954,9 @@
       </p:sp>
       <p:sp>
         <p:nvSpPr>
-          <p:cNvPr id="252" name="Google Shape;252;p17"/>
+          <p:cNvPr id="252" name="Google Shape;252;p17">
+            <a:hlinkClick action="ppaction://hlinksldjump" r:id="rId12"/>
+          </p:cNvPr>
           <p:cNvSpPr/>
           <p:nvPr/>
         </p:nvSpPr>
@@ -17989,7 +18017,9 @@
       </p:sp>
       <p:pic>
         <p:nvPicPr>
-          <p:cNvPr id="253" name="Google Shape;253;p17" title="correcciones sapiencia.png"/>
+          <p:cNvPr id="253" name="Google Shape;253;p17" title="correcciones sapiencia.png">
+            <a:hlinkClick action="ppaction://hlinksldjump" r:id="rId12"/>
+          </p:cNvPr>
           <p:cNvPicPr preferRelativeResize="0"/>
           <p:nvPr/>
         </p:nvPicPr>
@@ -21456,7 +21486,9 @@
       </p:sp>
       <p:sp>
         <p:nvSpPr>
-          <p:cNvPr id="308" name="Google Shape;308;p18"/>
+          <p:cNvPr id="308" name="Google Shape;308;p18">
+            <a:hlinkClick action="ppaction://hlinksldjump" r:id="rId12"/>
+          </p:cNvPr>
           <p:cNvSpPr/>
           <p:nvPr/>
         </p:nvSpPr>
@@ -21515,7 +21547,9 @@
       </p:sp>
       <p:sp>
         <p:nvSpPr>
-          <p:cNvPr id="309" name="Google Shape;309;p18"/>
+          <p:cNvPr id="309" name="Google Shape;309;p18">
+            <a:hlinkClick action="ppaction://hlinksldjump" r:id="rId12"/>
+          </p:cNvPr>
           <p:cNvSpPr/>
           <p:nvPr/>
         </p:nvSpPr>
@@ -21576,7 +21610,9 @@
       </p:sp>
       <p:pic>
         <p:nvPicPr>
-          <p:cNvPr id="310" name="Google Shape;310;p18" title="correcciones sapiencia.png"/>
+          <p:cNvPr id="310" name="Google Shape;310;p18" title="correcciones sapiencia.png">
+            <a:hlinkClick action="ppaction://hlinksldjump" r:id="rId12"/>
+          </p:cNvPr>
           <p:cNvPicPr preferRelativeResize="0"/>
           <p:nvPr/>
         </p:nvPicPr>
@@ -25550,7 +25586,9 @@
       </p:sp>
       <p:sp>
         <p:nvSpPr>
-          <p:cNvPr id="375" name="Google Shape;375;p19"/>
+          <p:cNvPr id="375" name="Google Shape;375;p19">
+            <a:hlinkClick action="ppaction://hlinksldjump" r:id="rId11"/>
+          </p:cNvPr>
           <p:cNvSpPr/>
           <p:nvPr/>
         </p:nvSpPr>
@@ -25609,7 +25647,9 @@
       </p:sp>
       <p:sp>
         <p:nvSpPr>
-          <p:cNvPr id="376" name="Google Shape;376;p19"/>
+          <p:cNvPr id="376" name="Google Shape;376;p19">
+            <a:hlinkClick action="ppaction://hlinksldjump" r:id="rId11"/>
+          </p:cNvPr>
           <p:cNvSpPr/>
           <p:nvPr/>
         </p:nvSpPr>
@@ -25670,7 +25710,9 @@
       </p:sp>
       <p:pic>
         <p:nvPicPr>
-          <p:cNvPr id="377" name="Google Shape;377;p19" title="correcciones sapiencia.png"/>
+          <p:cNvPr id="377" name="Google Shape;377;p19" title="correcciones sapiencia.png">
+            <a:hlinkClick action="ppaction://hlinksldjump" r:id="rId11"/>
+          </p:cNvPr>
           <p:cNvPicPr preferRelativeResize="0"/>
           <p:nvPr/>
         </p:nvPicPr>
@@ -28117,7 +28159,9 @@
       </p:sp>
       <p:sp>
         <p:nvSpPr>
-          <p:cNvPr id="375" name="Google Shape;375;p19"/>
+          <p:cNvPr id="375" name="Google Shape;375;p19">
+            <a:hlinkClick action="ppaction://hlinksldjump" r:id="rId3"/>
+          </p:cNvPr>
           <p:cNvSpPr/>
           <p:nvPr/>
         </p:nvSpPr>
@@ -28176,7 +28220,9 @@
       </p:sp>
       <p:sp>
         <p:nvSpPr>
-          <p:cNvPr id="376" name="Google Shape;376;p19"/>
+          <p:cNvPr id="376" name="Google Shape;376;p19">
+            <a:hlinkClick action="ppaction://hlinksldjump" r:id="rId3"/>
+          </p:cNvPr>
           <p:cNvSpPr/>
           <p:nvPr/>
         </p:nvSpPr>
@@ -28237,7 +28283,9 @@
       </p:sp>
       <p:pic>
         <p:nvPicPr>
-          <p:cNvPr id="377" name="Picture 376" descr="image.png"/>
+          <p:cNvPr id="377" name="Picture 376" descr="image.png">
+            <a:hlinkClick action="ppaction://hlinksldjump" r:id="rId3"/>
+          </p:cNvPr>
           <p:cNvPicPr>
             <a:picLocks noChangeAspect="1"/>
           </p:cNvPicPr>

</xml_diff>